<commit_message>
feat(addin): +8 estilos tipograficos (11 no total) + Regular/Bold
- Adiciona Label de Secao, Corpo de Texto, H3, H4, H5, Corpo de Pilar,
  Eyebrow, Caption (alguns Avenir Next Regular)
- applyTextStyle respeita style.bold (Regular vs Bold)
- Referencia regenerada (12 blocos, 2 colunas) com entrelinha sempre como
  MULTIPLO (spcPct: 0.8/0.9/0.95/1.0/1.15/1.3), space before/after zerados
- Cards de previa refletem peso Regular/Bold

Co-Authored-By: Claude Opus 4.8 <noreply@anthropic.com>
</commit_message>
<xml_diff>
--- a/v3-powerpoint-addin/assets/estilos-bg.pptx
+++ b/v3-powerpoint-addin/assets/estilos-bg.pptx
@@ -7,7 +7,7 @@
   <p:sldIdLst>
     <p:sldId id="256" r:id="rId7"/>
   </p:sldIdLst>
-  <p:sldSz cx="12191695" cy="12801600" type="screen4x3"/>
+  <p:sldSz cx="20104100" cy="11303000" type="screen4x3"/>
   <p:notesSz cx="6858000" cy="9144000"/>
   <p:defaultTextStyle>
     <a:defPPr>
@@ -3096,8 +3096,8 @@
         </p:nvSpPr>
         <p:spPr>
           <a:xfrm>
-            <a:off x="548640" y="274320"/>
-            <a:ext cx="10972800" cy="548640"/>
+            <a:off x="889000" y="304800"/>
+            <a:ext cx="18415000" cy="381000"/>
           </a:xfrm>
           <a:prstGeom prst="rect">
             <a:avLst/>
@@ -3111,13 +3111,13 @@
           <a:lstStyle/>
           <a:p>
             <a:r>
-              <a:rPr sz="1600" b="1">
+              <a:rPr sz="1500" b="1">
                 <a:solidFill>
                   <a:srgbClr val="76767C"/>
                 </a:solidFill>
                 <a:latin typeface="Avenir Next"/>
               </a:rPr>
-              <a:t>Estilos B+G — copie um bloco ou use o Pincel de Formatação. Apague este slide depois.</a:t>
+              <a:t>Estilos B+G — copie um bloco ou use o Pincel de Formatação (carrega a entrelinha). Apague este slide depois.</a:t>
             </a:r>
           </a:p>
         </p:txBody>
@@ -3130,8 +3130,8 @@
         </p:nvSpPr>
         <p:spPr>
           <a:xfrm>
-            <a:off x="548640" y="1005840"/>
-            <a:ext cx="10972800" cy="320040"/>
+            <a:off x="889000" y="914400"/>
+            <a:ext cx="8890000" cy="279400"/>
           </a:xfrm>
           <a:prstGeom prst="rect">
             <a:avLst/>
@@ -3139,13 +3139,13 @@
           <a:noFill/>
         </p:spPr>
         <p:txBody>
-          <a:bodyPr wrap="square">
+          <a:bodyPr wrap="none">
             <a:spAutoFit/>
           </a:bodyPr>
           <a:lstStyle/>
           <a:p>
             <a:r>
-              <a:rPr sz="1400" b="1">
+              <a:rPr sz="1200" b="1">
                 <a:solidFill>
                   <a:srgbClr val="76767C"/>
                 </a:solidFill>
@@ -3164,8 +3164,8 @@
         </p:nvSpPr>
         <p:spPr>
           <a:xfrm>
-            <a:off x="548640" y="1417320"/>
-            <a:ext cx="11064240" cy="2651760"/>
+            <a:off x="889000" y="1193800"/>
+            <a:ext cx="8890000" cy="2082800"/>
           </a:xfrm>
           <a:prstGeom prst="rect">
             <a:avLst/>
@@ -3176,7 +3176,7 @@
           </a:ln>
         </p:spPr>
         <p:txBody>
-          <a:bodyPr wrap="square" lIns="109728" rIns="109728" tIns="54864" bIns="54864">
+          <a:bodyPr wrap="square" lIns="101600" rIns="101600" tIns="50800" bIns="50800">
             <a:noAutofit/>
           </a:bodyPr>
           <a:lstStyle/>
@@ -3185,6 +3185,12 @@
               <a:lnSpc>
                 <a:spcPct val="80000"/>
               </a:lnSpc>
+              <a:spcBef>
+                <a:spcPts val="0"/>
+              </a:spcBef>
+              <a:spcAft>
+                <a:spcPts val="0"/>
+              </a:spcAft>
             </a:pPr>
             <a:r>
               <a:rPr sz="12000" b="1">
@@ -3215,8 +3221,8 @@
         </p:nvSpPr>
         <p:spPr>
           <a:xfrm>
-            <a:off x="548640" y="4114800"/>
-            <a:ext cx="10972800" cy="320040"/>
+            <a:off x="889000" y="3479800"/>
+            <a:ext cx="8890000" cy="279400"/>
           </a:xfrm>
           <a:prstGeom prst="rect">
             <a:avLst/>
@@ -3224,19 +3230,19 @@
           <a:noFill/>
         </p:spPr>
         <p:txBody>
-          <a:bodyPr wrap="square">
+          <a:bodyPr wrap="none">
             <a:spAutoFit/>
           </a:bodyPr>
           <a:lstStyle/>
           <a:p>
             <a:r>
-              <a:rPr sz="1400" b="1">
+              <a:rPr sz="1200" b="1">
                 <a:solidFill>
                   <a:srgbClr val="76767C"/>
                 </a:solidFill>
                 <a:latin typeface="Avenir Next"/>
               </a:rPr>
-              <a:t>HERO sobre fundo 436AE1 · branco</a:t>
+              <a:t>HERO sobre 436AE1 · branco</a:t>
             </a:r>
           </a:p>
         </p:txBody>
@@ -3249,8 +3255,8 @@
         </p:nvSpPr>
         <p:spPr>
           <a:xfrm>
-            <a:off x="548640" y="4526280"/>
-            <a:ext cx="11064240" cy="2651760"/>
+            <a:off x="889000" y="3759200"/>
+            <a:ext cx="8890000" cy="2082800"/>
           </a:xfrm>
           <a:prstGeom prst="rect">
             <a:avLst/>
@@ -3263,7 +3269,7 @@
           </a:ln>
         </p:spPr>
         <p:txBody>
-          <a:bodyPr wrap="square" lIns="109728" rIns="109728" tIns="54864" bIns="54864">
+          <a:bodyPr wrap="square" lIns="101600" rIns="101600" tIns="50800" bIns="50800">
             <a:noAutofit/>
           </a:bodyPr>
           <a:lstStyle/>
@@ -3272,6 +3278,12 @@
               <a:lnSpc>
                 <a:spcPct val="80000"/>
               </a:lnSpc>
+              <a:spcBef>
+                <a:spcPts val="0"/>
+              </a:spcBef>
+              <a:spcAft>
+                <a:spcPts val="0"/>
+              </a:spcAft>
             </a:pPr>
             <a:r>
               <a:rPr sz="12000" b="1">
@@ -3302,8 +3314,8 @@
         </p:nvSpPr>
         <p:spPr>
           <a:xfrm>
-            <a:off x="548640" y="7223760"/>
-            <a:ext cx="10972800" cy="320040"/>
+            <a:off x="889000" y="6045200"/>
+            <a:ext cx="8890000" cy="279400"/>
           </a:xfrm>
           <a:prstGeom prst="rect">
             <a:avLst/>
@@ -3311,13 +3323,13 @@
           <a:noFill/>
         </p:spPr>
         <p:txBody>
-          <a:bodyPr wrap="square">
+          <a:bodyPr wrap="none">
             <a:spAutoFit/>
           </a:bodyPr>
           <a:lstStyle/>
           <a:p>
             <a:r>
-              <a:rPr sz="1400" b="1">
+              <a:rPr sz="1200" b="1">
                 <a:solidFill>
                   <a:srgbClr val="76767C"/>
                 </a:solidFill>
@@ -3336,8 +3348,8 @@
         </p:nvSpPr>
         <p:spPr>
           <a:xfrm>
-            <a:off x="548640" y="7635240"/>
-            <a:ext cx="11064240" cy="2011680"/>
+            <a:off x="889000" y="6324600"/>
+            <a:ext cx="8890000" cy="1422400"/>
           </a:xfrm>
           <a:prstGeom prst="rect">
             <a:avLst/>
@@ -3348,7 +3360,7 @@
           </a:ln>
         </p:spPr>
         <p:txBody>
-          <a:bodyPr wrap="square" lIns="109728" rIns="109728" tIns="54864" bIns="54864">
+          <a:bodyPr wrap="square" lIns="101600" rIns="101600" tIns="50800" bIns="50800">
             <a:noAutofit/>
           </a:bodyPr>
           <a:lstStyle/>
@@ -3357,6 +3369,12 @@
               <a:lnSpc>
                 <a:spcPct val="90000"/>
               </a:lnSpc>
+              <a:spcBef>
+                <a:spcPts val="0"/>
+              </a:spcBef>
+              <a:spcAft>
+                <a:spcPts val="0"/>
+              </a:spcAft>
             </a:pPr>
             <a:r>
               <a:rPr sz="8000" b="1">
@@ -3367,15 +3385,6 @@
               </a:rPr>
               <a:t>Mega statement</a:t>
             </a:r>
-            <a:r>
-              <a:rPr sz="8000" b="1">
-                <a:solidFill>
-                  <a:srgbClr val="436AE1"/>
-                </a:solidFill>
-                <a:latin typeface="Avenir Next"/>
-              </a:rPr>
-              <a:t>.</a:t>
-            </a:r>
           </a:p>
         </p:txBody>
       </p:sp>
@@ -3387,8 +3396,8 @@
         </p:nvSpPr>
         <p:spPr>
           <a:xfrm>
-            <a:off x="548640" y="9692640"/>
-            <a:ext cx="10972800" cy="320040"/>
+            <a:off x="889000" y="7950200"/>
+            <a:ext cx="8890000" cy="279400"/>
           </a:xfrm>
           <a:prstGeom prst="rect">
             <a:avLst/>
@@ -3396,13 +3405,13 @@
           <a:noFill/>
         </p:spPr>
         <p:txBody>
-          <a:bodyPr wrap="square">
+          <a:bodyPr wrap="none">
             <a:spAutoFit/>
           </a:bodyPr>
           <a:lstStyle/>
           <a:p>
             <a:r>
-              <a:rPr sz="1400" b="1">
+              <a:rPr sz="1200" b="1">
                 <a:solidFill>
                   <a:srgbClr val="76767C"/>
                 </a:solidFill>
@@ -3421,8 +3430,8 @@
         </p:nvSpPr>
         <p:spPr>
           <a:xfrm>
-            <a:off x="548640" y="10104119"/>
-            <a:ext cx="11064240" cy="1554480"/>
+            <a:off x="889000" y="8229600"/>
+            <a:ext cx="8890000" cy="1079500"/>
           </a:xfrm>
           <a:prstGeom prst="rect">
             <a:avLst/>
@@ -3433,7 +3442,7 @@
           </a:ln>
         </p:spPr>
         <p:txBody>
-          <a:bodyPr wrap="square" lIns="109728" rIns="109728" tIns="54864" bIns="54864">
+          <a:bodyPr wrap="square" lIns="101600" rIns="101600" tIns="50800" bIns="50800">
             <a:noAutofit/>
           </a:bodyPr>
           <a:lstStyle/>
@@ -3442,6 +3451,12 @@
               <a:lnSpc>
                 <a:spcPct val="90000"/>
               </a:lnSpc>
+              <a:spcBef>
+                <a:spcPts val="0"/>
+              </a:spcBef>
+              <a:spcAft>
+                <a:spcPts val="0"/>
+              </a:spcAft>
             </a:pPr>
             <a:r>
               <a:rPr sz="6000" b="1">
@@ -3452,14 +3467,661 @@
               </a:rPr>
               <a:t>Título de página</a:t>
             </a:r>
-            <a:r>
-              <a:rPr sz="6000" b="1">
-                <a:solidFill>
-                  <a:srgbClr val="FC5E6D"/>
+          </a:p>
+        </p:txBody>
+      </p:sp>
+      <p:sp>
+        <p:nvSpPr>
+          <p:cNvPr id="11" name="TextBox 10"/>
+          <p:cNvSpPr txBox="1"/>
+          <p:nvPr/>
+        </p:nvSpPr>
+        <p:spPr>
+          <a:xfrm>
+            <a:off x="10312400" y="914400"/>
+            <a:ext cx="8890000" cy="279400"/>
+          </a:xfrm>
+          <a:prstGeom prst="rect">
+            <a:avLst/>
+          </a:prstGeom>
+          <a:noFill/>
+        </p:spPr>
+        <p:txBody>
+          <a:bodyPr wrap="none">
+            <a:spAutoFit/>
+          </a:bodyPr>
+          <a:lstStyle/>
+          <a:p>
+            <a:r>
+              <a:rPr sz="1200" b="1">
+                <a:solidFill>
+                  <a:srgbClr val="76767C"/>
                 </a:solidFill>
                 <a:latin typeface="Avenir Next"/>
               </a:rPr>
-              <a:t>.</a:t>
+              <a:t>LABEL DE SEÇÃO · 60pt · 0.9x</a:t>
+            </a:r>
+          </a:p>
+        </p:txBody>
+      </p:sp>
+      <p:sp>
+        <p:nvSpPr>
+          <p:cNvPr id="12" name="TextBox 11"/>
+          <p:cNvSpPr txBox="1"/>
+          <p:nvPr/>
+        </p:nvSpPr>
+        <p:spPr>
+          <a:xfrm>
+            <a:off x="10312400" y="1193800"/>
+            <a:ext cx="8890000" cy="1079500"/>
+          </a:xfrm>
+          <a:prstGeom prst="rect">
+            <a:avLst/>
+          </a:prstGeom>
+          <a:noFill/>
+          <a:ln>
+            <a:noFill/>
+          </a:ln>
+        </p:spPr>
+        <p:txBody>
+          <a:bodyPr wrap="square" lIns="101600" rIns="101600" tIns="50800" bIns="50800">
+            <a:noAutofit/>
+          </a:bodyPr>
+          <a:lstStyle/>
+          <a:p>
+            <a:pPr algn="l">
+              <a:lnSpc>
+                <a:spcPct val="90000"/>
+              </a:lnSpc>
+              <a:spcBef>
+                <a:spcPts val="0"/>
+              </a:spcBef>
+              <a:spcAft>
+                <a:spcPts val="0"/>
+              </a:spcAft>
+            </a:pPr>
+            <a:r>
+              <a:rPr sz="6000" b="1">
+                <a:solidFill>
+                  <a:srgbClr val="FC5E6D"/>
+                </a:solidFill>
+                <a:latin typeface="Avenir Next"/>
+              </a:rPr>
+              <a:t>Label de seção</a:t>
+            </a:r>
+          </a:p>
+        </p:txBody>
+      </p:sp>
+      <p:sp>
+        <p:nvSpPr>
+          <p:cNvPr id="13" name="TextBox 12"/>
+          <p:cNvSpPr txBox="1"/>
+          <p:nvPr/>
+        </p:nvSpPr>
+        <p:spPr>
+          <a:xfrm>
+            <a:off x="10312400" y="2476500"/>
+            <a:ext cx="8890000" cy="279400"/>
+          </a:xfrm>
+          <a:prstGeom prst="rect">
+            <a:avLst/>
+          </a:prstGeom>
+          <a:noFill/>
+        </p:spPr>
+        <p:txBody>
+          <a:bodyPr wrap="none">
+            <a:spAutoFit/>
+          </a:bodyPr>
+          <a:lstStyle/>
+          <a:p>
+            <a:r>
+              <a:rPr sz="1200" b="1">
+                <a:solidFill>
+                  <a:srgbClr val="76767C"/>
+                </a:solidFill>
+                <a:latin typeface="Avenir Next"/>
+              </a:rPr>
+              <a:t>CORPO DE TEXTO · 44pt · 1.15x · Reg</a:t>
+            </a:r>
+          </a:p>
+        </p:txBody>
+      </p:sp>
+      <p:sp>
+        <p:nvSpPr>
+          <p:cNvPr id="14" name="TextBox 13"/>
+          <p:cNvSpPr txBox="1"/>
+          <p:nvPr/>
+        </p:nvSpPr>
+        <p:spPr>
+          <a:xfrm>
+            <a:off x="10312400" y="2755900"/>
+            <a:ext cx="8890000" cy="812800"/>
+          </a:xfrm>
+          <a:prstGeom prst="rect">
+            <a:avLst/>
+          </a:prstGeom>
+          <a:noFill/>
+          <a:ln>
+            <a:noFill/>
+          </a:ln>
+        </p:spPr>
+        <p:txBody>
+          <a:bodyPr wrap="square" lIns="101600" rIns="101600" tIns="50800" bIns="50800">
+            <a:noAutofit/>
+          </a:bodyPr>
+          <a:lstStyle/>
+          <a:p>
+            <a:pPr algn="l">
+              <a:lnSpc>
+                <a:spcPct val="115000"/>
+              </a:lnSpc>
+              <a:spcBef>
+                <a:spcPts val="0"/>
+              </a:spcBef>
+              <a:spcAft>
+                <a:spcPts val="0"/>
+              </a:spcAft>
+            </a:pPr>
+            <a:r>
+              <a:rPr sz="4400" b="0">
+                <a:solidFill>
+                  <a:srgbClr val="436AE1"/>
+                </a:solidFill>
+                <a:latin typeface="Avenir Next"/>
+              </a:rPr>
+              <a:t>Corpo de texto</a:t>
+            </a:r>
+          </a:p>
+        </p:txBody>
+      </p:sp>
+      <p:sp>
+        <p:nvSpPr>
+          <p:cNvPr id="15" name="TextBox 14"/>
+          <p:cNvSpPr txBox="1"/>
+          <p:nvPr/>
+        </p:nvSpPr>
+        <p:spPr>
+          <a:xfrm>
+            <a:off x="10312400" y="3771900"/>
+            <a:ext cx="8890000" cy="279400"/>
+          </a:xfrm>
+          <a:prstGeom prst="rect">
+            <a:avLst/>
+          </a:prstGeom>
+          <a:noFill/>
+        </p:spPr>
+        <p:txBody>
+          <a:bodyPr wrap="none">
+            <a:spAutoFit/>
+          </a:bodyPr>
+          <a:lstStyle/>
+          <a:p>
+            <a:r>
+              <a:rPr sz="1200" b="1">
+                <a:solidFill>
+                  <a:srgbClr val="76767C"/>
+                </a:solidFill>
+                <a:latin typeface="Avenir Next"/>
+              </a:rPr>
+              <a:t>H3 CORPO DESCRITIVO · 34pt · 0.95x</a:t>
+            </a:r>
+          </a:p>
+        </p:txBody>
+      </p:sp>
+      <p:sp>
+        <p:nvSpPr>
+          <p:cNvPr id="16" name="TextBox 15"/>
+          <p:cNvSpPr txBox="1"/>
+          <p:nvPr/>
+        </p:nvSpPr>
+        <p:spPr>
+          <a:xfrm>
+            <a:off x="10312400" y="4051300"/>
+            <a:ext cx="8890000" cy="647700"/>
+          </a:xfrm>
+          <a:prstGeom prst="rect">
+            <a:avLst/>
+          </a:prstGeom>
+          <a:noFill/>
+          <a:ln>
+            <a:noFill/>
+          </a:ln>
+        </p:spPr>
+        <p:txBody>
+          <a:bodyPr wrap="square" lIns="101600" rIns="101600" tIns="50800" bIns="50800">
+            <a:noAutofit/>
+          </a:bodyPr>
+          <a:lstStyle/>
+          <a:p>
+            <a:pPr algn="l">
+              <a:lnSpc>
+                <a:spcPct val="95000"/>
+              </a:lnSpc>
+              <a:spcBef>
+                <a:spcPts val="0"/>
+              </a:spcBef>
+              <a:spcAft>
+                <a:spcPts val="0"/>
+              </a:spcAft>
+            </a:pPr>
+            <a:r>
+              <a:rPr sz="3400" b="1">
+                <a:solidFill>
+                  <a:srgbClr val="FC5E6D"/>
+                </a:solidFill>
+                <a:latin typeface="Avenir Next"/>
+              </a:rPr>
+              <a:t>Corpo descritivo</a:t>
+            </a:r>
+          </a:p>
+        </p:txBody>
+      </p:sp>
+      <p:sp>
+        <p:nvSpPr>
+          <p:cNvPr id="17" name="TextBox 16"/>
+          <p:cNvSpPr txBox="1"/>
+          <p:nvPr/>
+        </p:nvSpPr>
+        <p:spPr>
+          <a:xfrm>
+            <a:off x="10312400" y="4902200"/>
+            <a:ext cx="8890000" cy="279400"/>
+          </a:xfrm>
+          <a:prstGeom prst="rect">
+            <a:avLst/>
+          </a:prstGeom>
+          <a:noFill/>
+        </p:spPr>
+        <p:txBody>
+          <a:bodyPr wrap="none">
+            <a:spAutoFit/>
+          </a:bodyPr>
+          <a:lstStyle/>
+          <a:p>
+            <a:r>
+              <a:rPr sz="1200" b="1">
+                <a:solidFill>
+                  <a:srgbClr val="76767C"/>
+                </a:solidFill>
+                <a:latin typeface="Avenir Next"/>
+              </a:rPr>
+              <a:t>H4 SUBTÍTULO DE PILAR · 28pt · 1.0x</a:t>
+            </a:r>
+          </a:p>
+        </p:txBody>
+      </p:sp>
+      <p:sp>
+        <p:nvSpPr>
+          <p:cNvPr id="18" name="TextBox 17"/>
+          <p:cNvSpPr txBox="1"/>
+          <p:nvPr/>
+        </p:nvSpPr>
+        <p:spPr>
+          <a:xfrm>
+            <a:off x="10312400" y="5181600"/>
+            <a:ext cx="8890000" cy="546100"/>
+          </a:xfrm>
+          <a:prstGeom prst="rect">
+            <a:avLst/>
+          </a:prstGeom>
+          <a:noFill/>
+          <a:ln>
+            <a:noFill/>
+          </a:ln>
+        </p:spPr>
+        <p:txBody>
+          <a:bodyPr wrap="square" lIns="101600" rIns="101600" tIns="50800" bIns="50800">
+            <a:noAutofit/>
+          </a:bodyPr>
+          <a:lstStyle/>
+          <a:p>
+            <a:pPr algn="l">
+              <a:lnSpc>
+                <a:spcPct val="100000"/>
+              </a:lnSpc>
+              <a:spcBef>
+                <a:spcPts val="0"/>
+              </a:spcBef>
+              <a:spcAft>
+                <a:spcPts val="0"/>
+              </a:spcAft>
+            </a:pPr>
+            <a:r>
+              <a:rPr sz="2800" b="1">
+                <a:solidFill>
+                  <a:srgbClr val="436AE1"/>
+                </a:solidFill>
+                <a:latin typeface="Avenir Next"/>
+              </a:rPr>
+              <a:t>Subtítulo de pilar</a:t>
+            </a:r>
+          </a:p>
+        </p:txBody>
+      </p:sp>
+      <p:sp>
+        <p:nvSpPr>
+          <p:cNvPr id="19" name="TextBox 18"/>
+          <p:cNvSpPr txBox="1"/>
+          <p:nvPr/>
+        </p:nvSpPr>
+        <p:spPr>
+          <a:xfrm>
+            <a:off x="10312400" y="5930900"/>
+            <a:ext cx="8890000" cy="279400"/>
+          </a:xfrm>
+          <a:prstGeom prst="rect">
+            <a:avLst/>
+          </a:prstGeom>
+          <a:noFill/>
+        </p:spPr>
+        <p:txBody>
+          <a:bodyPr wrap="none">
+            <a:spAutoFit/>
+          </a:bodyPr>
+          <a:lstStyle/>
+          <a:p>
+            <a:r>
+              <a:rPr sz="1200" b="1">
+                <a:solidFill>
+                  <a:srgbClr val="76767C"/>
+                </a:solidFill>
+                <a:latin typeface="Avenir Next"/>
+              </a:rPr>
+              <a:t>H5 TEXTO DESCRITIVO · 24pt · 1.0x · Reg</a:t>
+            </a:r>
+          </a:p>
+        </p:txBody>
+      </p:sp>
+      <p:sp>
+        <p:nvSpPr>
+          <p:cNvPr id="20" name="TextBox 19"/>
+          <p:cNvSpPr txBox="1"/>
+          <p:nvPr/>
+        </p:nvSpPr>
+        <p:spPr>
+          <a:xfrm>
+            <a:off x="10312400" y="6210300"/>
+            <a:ext cx="8890000" cy="482600"/>
+          </a:xfrm>
+          <a:prstGeom prst="rect">
+            <a:avLst/>
+          </a:prstGeom>
+          <a:noFill/>
+          <a:ln>
+            <a:noFill/>
+          </a:ln>
+        </p:spPr>
+        <p:txBody>
+          <a:bodyPr wrap="square" lIns="101600" rIns="101600" tIns="50800" bIns="50800">
+            <a:noAutofit/>
+          </a:bodyPr>
+          <a:lstStyle/>
+          <a:p>
+            <a:pPr algn="l">
+              <a:lnSpc>
+                <a:spcPct val="100000"/>
+              </a:lnSpc>
+              <a:spcBef>
+                <a:spcPts val="0"/>
+              </a:spcBef>
+              <a:spcAft>
+                <a:spcPts val="0"/>
+              </a:spcAft>
+            </a:pPr>
+            <a:r>
+              <a:rPr sz="2400" b="0">
+                <a:solidFill>
+                  <a:srgbClr val="436AE1"/>
+                </a:solidFill>
+                <a:latin typeface="Avenir Next"/>
+              </a:rPr>
+              <a:t>Texto descritivo</a:t>
+            </a:r>
+          </a:p>
+        </p:txBody>
+      </p:sp>
+      <p:sp>
+        <p:nvSpPr>
+          <p:cNvPr id="21" name="TextBox 20"/>
+          <p:cNvSpPr txBox="1"/>
+          <p:nvPr/>
+        </p:nvSpPr>
+        <p:spPr>
+          <a:xfrm>
+            <a:off x="10312400" y="6896100"/>
+            <a:ext cx="8890000" cy="279400"/>
+          </a:xfrm>
+          <a:prstGeom prst="rect">
+            <a:avLst/>
+          </a:prstGeom>
+          <a:noFill/>
+        </p:spPr>
+        <p:txBody>
+          <a:bodyPr wrap="none">
+            <a:spAutoFit/>
+          </a:bodyPr>
+          <a:lstStyle/>
+          <a:p>
+            <a:r>
+              <a:rPr sz="1200" b="1">
+                <a:solidFill>
+                  <a:srgbClr val="76767C"/>
+                </a:solidFill>
+                <a:latin typeface="Avenir Next"/>
+              </a:rPr>
+              <a:t>CORPO DE PILAR · 20pt · 1.3x · Reg</a:t>
+            </a:r>
+          </a:p>
+        </p:txBody>
+      </p:sp>
+      <p:sp>
+        <p:nvSpPr>
+          <p:cNvPr id="22" name="TextBox 21"/>
+          <p:cNvSpPr txBox="1"/>
+          <p:nvPr/>
+        </p:nvSpPr>
+        <p:spPr>
+          <a:xfrm>
+            <a:off x="10312400" y="7175500"/>
+            <a:ext cx="8890000" cy="406400"/>
+          </a:xfrm>
+          <a:prstGeom prst="rect">
+            <a:avLst/>
+          </a:prstGeom>
+          <a:noFill/>
+          <a:ln>
+            <a:noFill/>
+          </a:ln>
+        </p:spPr>
+        <p:txBody>
+          <a:bodyPr wrap="square" lIns="101600" rIns="101600" tIns="50800" bIns="50800">
+            <a:noAutofit/>
+          </a:bodyPr>
+          <a:lstStyle/>
+          <a:p>
+            <a:pPr algn="l">
+              <a:lnSpc>
+                <a:spcPct val="130000"/>
+              </a:lnSpc>
+              <a:spcBef>
+                <a:spcPts val="0"/>
+              </a:spcBef>
+              <a:spcAft>
+                <a:spcPts val="0"/>
+              </a:spcAft>
+            </a:pPr>
+            <a:r>
+              <a:rPr sz="2000" b="0">
+                <a:solidFill>
+                  <a:srgbClr val="436AE1"/>
+                </a:solidFill>
+                <a:latin typeface="Avenir Next"/>
+              </a:rPr>
+              <a:t>Corpo de pilar</a:t>
+            </a:r>
+          </a:p>
+        </p:txBody>
+      </p:sp>
+      <p:sp>
+        <p:nvSpPr>
+          <p:cNvPr id="23" name="TextBox 22"/>
+          <p:cNvSpPr txBox="1"/>
+          <p:nvPr/>
+        </p:nvSpPr>
+        <p:spPr>
+          <a:xfrm>
+            <a:off x="10312400" y="7785100"/>
+            <a:ext cx="8890000" cy="279400"/>
+          </a:xfrm>
+          <a:prstGeom prst="rect">
+            <a:avLst/>
+          </a:prstGeom>
+          <a:noFill/>
+        </p:spPr>
+        <p:txBody>
+          <a:bodyPr wrap="none">
+            <a:spAutoFit/>
+          </a:bodyPr>
+          <a:lstStyle/>
+          <a:p>
+            <a:r>
+              <a:rPr sz="1200" b="1">
+                <a:solidFill>
+                  <a:srgbClr val="76767C"/>
+                </a:solidFill>
+                <a:latin typeface="Avenir Next"/>
+              </a:rPr>
+              <a:t>LABEL / EYEBROW · 18pt · 1.0x</a:t>
+            </a:r>
+          </a:p>
+        </p:txBody>
+      </p:sp>
+      <p:sp>
+        <p:nvSpPr>
+          <p:cNvPr id="24" name="TextBox 23"/>
+          <p:cNvSpPr txBox="1"/>
+          <p:nvPr/>
+        </p:nvSpPr>
+        <p:spPr>
+          <a:xfrm>
+            <a:off x="10312400" y="8064500"/>
+            <a:ext cx="8890000" cy="381000"/>
+          </a:xfrm>
+          <a:prstGeom prst="rect">
+            <a:avLst/>
+          </a:prstGeom>
+          <a:noFill/>
+          <a:ln>
+            <a:noFill/>
+          </a:ln>
+        </p:spPr>
+        <p:txBody>
+          <a:bodyPr wrap="square" lIns="101600" rIns="101600" tIns="50800" bIns="50800">
+            <a:noAutofit/>
+          </a:bodyPr>
+          <a:lstStyle/>
+          <a:p>
+            <a:pPr algn="l">
+              <a:lnSpc>
+                <a:spcPct val="100000"/>
+              </a:lnSpc>
+              <a:spcBef>
+                <a:spcPts val="0"/>
+              </a:spcBef>
+              <a:spcAft>
+                <a:spcPts val="0"/>
+              </a:spcAft>
+            </a:pPr>
+            <a:r>
+              <a:rPr sz="1800" b="1">
+                <a:solidFill>
+                  <a:srgbClr val="FC5E6D"/>
+                </a:solidFill>
+                <a:latin typeface="Avenir Next"/>
+              </a:rPr>
+              <a:t>Label / eyebrow</a:t>
+            </a:r>
+          </a:p>
+        </p:txBody>
+      </p:sp>
+      <p:sp>
+        <p:nvSpPr>
+          <p:cNvPr id="25" name="TextBox 24"/>
+          <p:cNvSpPr txBox="1"/>
+          <p:nvPr/>
+        </p:nvSpPr>
+        <p:spPr>
+          <a:xfrm>
+            <a:off x="10312400" y="8648700"/>
+            <a:ext cx="8890000" cy="279400"/>
+          </a:xfrm>
+          <a:prstGeom prst="rect">
+            <a:avLst/>
+          </a:prstGeom>
+          <a:noFill/>
+        </p:spPr>
+        <p:txBody>
+          <a:bodyPr wrap="none">
+            <a:spAutoFit/>
+          </a:bodyPr>
+          <a:lstStyle/>
+          <a:p>
+            <a:r>
+              <a:rPr sz="1200" b="1">
+                <a:solidFill>
+                  <a:srgbClr val="76767C"/>
+                </a:solidFill>
+                <a:latin typeface="Avenir Next"/>
+              </a:rPr>
+              <a:t>LEGENDA / CAPTION · 16pt · 1.3x · Reg</a:t>
+            </a:r>
+          </a:p>
+        </p:txBody>
+      </p:sp>
+      <p:sp>
+        <p:nvSpPr>
+          <p:cNvPr id="26" name="TextBox 25"/>
+          <p:cNvSpPr txBox="1"/>
+          <p:nvPr/>
+        </p:nvSpPr>
+        <p:spPr>
+          <a:xfrm>
+            <a:off x="10312400" y="8928100"/>
+            <a:ext cx="8890000" cy="342900"/>
+          </a:xfrm>
+          <a:prstGeom prst="rect">
+            <a:avLst/>
+          </a:prstGeom>
+          <a:noFill/>
+          <a:ln>
+            <a:noFill/>
+          </a:ln>
+        </p:spPr>
+        <p:txBody>
+          <a:bodyPr wrap="square" lIns="101600" rIns="101600" tIns="50800" bIns="50800">
+            <a:noAutofit/>
+          </a:bodyPr>
+          <a:lstStyle/>
+          <a:p>
+            <a:pPr algn="l">
+              <a:lnSpc>
+                <a:spcPct val="130000"/>
+              </a:lnSpc>
+              <a:spcBef>
+                <a:spcPts val="0"/>
+              </a:spcBef>
+              <a:spcAft>
+                <a:spcPts val="0"/>
+              </a:spcAft>
+            </a:pPr>
+            <a:r>
+              <a:rPr sz="1600" b="0">
+                <a:solidFill>
+                  <a:srgbClr val="436AE1"/>
+                </a:solidFill>
+                <a:latin typeface="Avenir Next"/>
+              </a:rPr>
+              <a:t>Legenda / caption</a:t>
             </a:r>
           </a:p>
         </p:txBody>

</xml_diff>